<commit_message>
docs: simplify pitch footers and refresh final verified exports
</commit_message>
<xml_diff>
--- a/pitch/output/MetroQuest-Pitch-2026.pptx
+++ b/pitch/output/MetroQuest-Pitch-2026.pptx
@@ -8062,7 +8062,7 @@
                   <a:srgbClr val="B3B3B3"/>
                 </a:solidFill>
               </a:rPr>
-              <a:t>Prototype: manual rides, local data, simulated social ranks. No APK delivered.</a:t>
+              <a:t>Prototype: manual rides, local data, simulated social ranks.</a:t>
             </a:r>
             <a:endParaRPr sz="1100">
               <a:solidFill>
@@ -8681,7 +8681,7 @@
                   <a:srgbClr val="B3B3B3"/>
                 </a:solidFill>
               </a:rPr>
-              <a:t>Ideas to validate. No customers, paid pilots or revenue claimed.</a:t>
+              <a:t>Ideas to validate through a Pune pilot.</a:t>
             </a:r>
             <a:endParaRPr sz="1200">
               <a:solidFill>

</xml_diff>